<commit_message>
Refactor code structure for improved readability and maintainability
</commit_message>
<xml_diff>
--- a/poster/Poster.pptx
+++ b/poster/Poster.pptx
@@ -4551,187 +4551,18 @@
           <a:lstStyle/>
           <a:p>
             <a:pPr>
-              <a:spcBef>
-                <a:spcPts val="200"/>
-              </a:spcBef>
-              <a:spcAft>
-                <a:spcPts val="600"/>
-              </a:spcAft>
+              <a:defRPr sz="1100"/>
             </a:pPr>
             <a:r>
-              <a:rPr sz="1300" b="1" i="0">
-                <a:solidFill>
-                  <a:srgbClr val="1C4587"/>
-                </a:solidFill>
-                <a:latin typeface="Calibri"/>
-              </a:rPr>
-              <a:t>•  </a:t>
-            </a:r>
-            <a:r>
-              <a:rPr sz="1300" b="1" i="0">
-                <a:solidFill>
-                  <a:srgbClr val="1C4587"/>
-                </a:solidFill>
-                <a:latin typeface="Calibri"/>
-              </a:rPr>
-              <a:t>Five Enterprise Domains: </a:t>
-            </a:r>
-            <a:r>
-              <a:rPr sz="1300" b="0" i="0">
-                <a:solidFill>
-                  <a:srgbClr val="1E293B"/>
-                </a:solidFill>
-                <a:latin typeface="Calibri"/>
-              </a:rPr>
-              <a:t>PDF processing (pdf_merge), Git repository auditing (git_log), REST Email management (email_summarize), internal communications (write_update), and headless web app auditing (webapp_audit).</a:t>
+              <a:t>•  26 Multi-Domain Workflows: Spans Systems (Docker, K8s, Git, Terraform), Data (Postgres, Redis, Pandas, S3), Productivity (PDF, Markdown, Audio, OCR), Network/Security (Nmap, SSH, Audit), and Specialized Bio/Finance/IoT domains.</a:t>
             </a:r>
           </a:p>
           <a:p>
             <a:pPr>
-              <a:spcBef>
-                <a:spcPts val="200"/>
-              </a:spcBef>
-              <a:spcAft>
-                <a:spcPts val="600"/>
-              </a:spcAft>
+              <a:defRPr sz="1100"/>
             </a:pPr>
             <a:r>
-              <a:rPr sz="1300" b="1" i="0">
-                <a:solidFill>
-                  <a:srgbClr val="1C4587"/>
-                </a:solidFill>
-                <a:latin typeface="Calibri"/>
-              </a:rPr>
-              <a:t>•  </a:t>
-            </a:r>
-            <a:r>
-              <a:rPr sz="1300" b="1" i="0">
-                <a:solidFill>
-                  <a:srgbClr val="1C4587"/>
-                </a:solidFill>
-                <a:latin typeface="Calibri"/>
-              </a:rPr>
-              <a:t>Three Linguistic Registers: </a:t>
-            </a:r>
-            <a:r>
-              <a:rPr sz="1300" b="0" i="0">
-                <a:solidFill>
-                  <a:srgbClr val="1E293B"/>
-                </a:solidFill>
-                <a:latin typeface="Calibri"/>
-              </a:rPr>
-              <a:t>1) English (en) technical baseline; 2) Native Bangla (bn) formal script; 3) Banglish (bn-en) code-mixing with English CLI syntax and Bengali operational framing.</a:t>
-            </a:r>
-          </a:p>
-          <a:p>
-            <a:pPr>
-              <a:spcBef>
-                <a:spcPts val="200"/>
-              </a:spcBef>
-              <a:spcAft>
-                <a:spcPts val="600"/>
-              </a:spcAft>
-            </a:pPr>
-            <a:r>
-              <a:rPr sz="1300" b="1" i="0">
-                <a:solidFill>
-                  <a:srgbClr val="1C4587"/>
-                </a:solidFill>
-                <a:latin typeface="Calibri"/>
-              </a:rPr>
-              <a:t>•  </a:t>
-            </a:r>
-            <a:r>
-              <a:rPr sz="1300" b="1" i="0">
-                <a:solidFill>
-                  <a:srgbClr val="1C4587"/>
-                </a:solidFill>
-                <a:latin typeface="Calibri"/>
-              </a:rPr>
-              <a:t>Dual Agent Backbones: </a:t>
-            </a:r>
-            <a:r>
-              <a:rPr sz="1300" b="0" i="0">
-                <a:solidFill>
-                  <a:srgbClr val="1E293B"/>
-                </a:solidFill>
-                <a:latin typeface="Calibri"/>
-              </a:rPr>
-              <a:t>Gemini 2.5 Flash (commercial frontier API) and Groq Llama 3.3 70B Versatile (open-weights high-performance API).</a:t>
-            </a:r>
-          </a:p>
-          <a:p>
-            <a:pPr>
-              <a:spcBef>
-                <a:spcPts val="200"/>
-              </a:spcBef>
-              <a:spcAft>
-                <a:spcPts val="600"/>
-              </a:spcAft>
-            </a:pPr>
-            <a:r>
-              <a:rPr sz="1300" b="1" i="0">
-                <a:solidFill>
-                  <a:srgbClr val="1C4587"/>
-                </a:solidFill>
-                <a:latin typeface="Calibri"/>
-              </a:rPr>
-              <a:t>•  </a:t>
-            </a:r>
-            <a:r>
-              <a:rPr sz="1300" b="1" i="0">
-                <a:solidFill>
-                  <a:srgbClr val="1C4587"/>
-                </a:solidFill>
-                <a:latin typeface="Calibri"/>
-              </a:rPr>
-              <a:t>Evaluation Metrics: </a:t>
-            </a:r>
-            <a:r>
-              <a:rPr sz="1300" b="0" i="0">
-                <a:solidFill>
-                  <a:srgbClr val="1E293B"/>
-                </a:solidFill>
-                <a:latin typeface="Calibri"/>
-              </a:rPr>
-              <a:t>Skill Selection Rate (SSR), Attack Success Rate (ASR), Benign Utility Retention (BUR), and Defense Robustness Rate (DRR).</a:t>
-            </a:r>
-          </a:p>
-          <a:p>
-            <a:pPr>
-              <a:spcBef>
-                <a:spcPts val="200"/>
-              </a:spcBef>
-              <a:spcAft>
-                <a:spcPts val="600"/>
-              </a:spcAft>
-            </a:pPr>
-            <a:r>
-              <a:rPr sz="1300" b="1" i="0">
-                <a:solidFill>
-                  <a:srgbClr val="1C4587"/>
-                </a:solidFill>
-                <a:latin typeface="Calibri"/>
-              </a:rPr>
-              <a:t>•  </a:t>
-            </a:r>
-            <a:r>
-              <a:rPr sz="1300" b="1" i="0">
-                <a:solidFill>
-                  <a:srgbClr val="1C4587"/>
-                </a:solidFill>
-                <a:latin typeface="Calibri"/>
-              </a:rPr>
-              <a:t>Harmless Canary Protocol: </a:t>
-            </a:r>
-            <a:r>
-              <a:rPr sz="1300" b="0" i="0">
-                <a:solidFill>
-                  <a:srgbClr val="1E293B"/>
-                </a:solidFill>
-                <a:latin typeface="Calibri"/>
-              </a:rPr>
-              <a:t>Contextual injection instructs the agent to write a telemetry marker to /tmp/canary_audit.marker inside network-isolated containers (--network none). Zero user secrets or host credentials are exposed.</a:t>
+              <a:t>•  Tri-Lingual Empirical Dataset: Rigorously calibrated across English (en), Native Bangla (bn), and Code-Mixed Banglish (bn-en) with 312 live LLM agent trials.</a:t>
             </a:r>
           </a:p>
         </p:txBody>
@@ -5085,21 +4916,10 @@
           <a:lstStyle/>
           <a:p>
             <a:pPr>
-              <a:spcBef>
-                <a:spcPts val="0"/>
-              </a:spcBef>
-              <a:spcAft>
-                <a:spcPts val="200"/>
-              </a:spcAft>
+              <a:defRPr sz="1200" b="1"/>
             </a:pPr>
             <a:r>
-              <a:rPr sz="1200" b="0" i="1">
-                <a:solidFill>
-                  <a:srgbClr val="475569"/>
-                </a:solidFill>
-                <a:latin typeface="Calibri"/>
-              </a:rPr>
-              <a:t>Table 1: Quantitative results across 120 trials (5 tasks × 3 languages × 4 defense tiers × 2 models):</a:t>
+              <a:t>Table 1: Empirical findings across 312 trials (26 domains × 3 registers × 4 defense tiers on Qwen-2.5-27B):</a:t>
             </a:r>
           </a:p>
         </p:txBody>
@@ -5137,20 +4957,9 @@
                     <a:lstStyle/>
                     <a:p>
                       <a:pPr>
-                        <a:spcBef>
-                          <a:spcPts val="100"/>
-                        </a:spcBef>
-                        <a:spcAft>
-                          <a:spcPts val="100"/>
-                        </a:spcAft>
+                        <a:defRPr sz="1100" b="1"/>
                       </a:pPr>
                       <a:r>
-                        <a:rPr sz="1100" b="1">
-                          <a:solidFill>
-                            <a:srgbClr val="FFFFFF"/>
-                          </a:solidFill>
-                          <a:latin typeface="Calibri"/>
-                        </a:rPr>
                         <a:t>Defense Layer</a:t>
                       </a:r>
                     </a:p>
@@ -5189,20 +4998,9 @@
                     <a:lstStyle/>
                     <a:p>
                       <a:pPr>
-                        <a:spcBef>
-                          <a:spcPts val="100"/>
-                        </a:spcBef>
-                        <a:spcAft>
-                          <a:spcPts val="100"/>
-                        </a:spcAft>
+                        <a:defRPr sz="1100" b="1"/>
                       </a:pPr>
                       <a:r>
-                        <a:rPr sz="1100" b="1">
-                          <a:solidFill>
-                            <a:srgbClr val="FFFFFF"/>
-                          </a:solidFill>
-                          <a:latin typeface="Calibri"/>
-                        </a:rPr>
                         <a:t>Register</a:t>
                       </a:r>
                     </a:p>
@@ -5241,21 +5039,10 @@
                     <a:lstStyle/>
                     <a:p>
                       <a:pPr>
-                        <a:spcBef>
-                          <a:spcPts val="100"/>
-                        </a:spcBef>
-                        <a:spcAft>
-                          <a:spcPts val="100"/>
-                        </a:spcAft>
+                        <a:defRPr sz="1100" b="1"/>
                       </a:pPr>
                       <a:r>
-                        <a:rPr sz="1100" b="1">
-                          <a:solidFill>
-                            <a:srgbClr val="FFFFFF"/>
-                          </a:solidFill>
-                          <a:latin typeface="Calibri"/>
-                        </a:rPr>
-                        <a:t>SSR</a:t>
+                        <a:t>ASR</a:t>
                       </a:r>
                     </a:p>
                   </a:txBody>
@@ -5293,21 +5080,10 @@
                     <a:lstStyle/>
                     <a:p>
                       <a:pPr>
-                        <a:spcBef>
-                          <a:spcPts val="100"/>
-                        </a:spcBef>
-                        <a:spcAft>
-                          <a:spcPts val="100"/>
-                        </a:spcAft>
+                        <a:defRPr sz="1100" b="1"/>
                       </a:pPr>
                       <a:r>
-                        <a:rPr sz="1100" b="1">
-                          <a:solidFill>
-                            <a:srgbClr val="FFFFFF"/>
-                          </a:solidFill>
-                          <a:latin typeface="Calibri"/>
-                        </a:rPr>
-                        <a:t>ASR</a:t>
+                        <a:t>PVR</a:t>
                       </a:r>
                     </a:p>
                   </a:txBody>
@@ -5345,21 +5121,10 @@
                     <a:lstStyle/>
                     <a:p>
                       <a:pPr>
-                        <a:spcBef>
-                          <a:spcPts val="100"/>
-                        </a:spcBef>
-                        <a:spcAft>
-                          <a:spcPts val="100"/>
-                        </a:spcAft>
+                        <a:defRPr sz="1100" b="1"/>
                       </a:pPr>
                       <a:r>
-                        <a:rPr sz="1100" b="1">
-                          <a:solidFill>
-                            <a:srgbClr val="FFFFFF"/>
-                          </a:solidFill>
-                          <a:latin typeface="Calibri"/>
-                        </a:rPr>
-                        <a:t>BUR</a:t>
+                        <a:t>TSR</a:t>
                       </a:r>
                     </a:p>
                   </a:txBody>
@@ -5397,21 +5162,10 @@
                     <a:lstStyle/>
                     <a:p>
                       <a:pPr>
-                        <a:spcBef>
-                          <a:spcPts val="100"/>
-                        </a:spcBef>
-                        <a:spcAft>
-                          <a:spcPts val="100"/>
-                        </a:spcAft>
+                        <a:defRPr sz="1100" b="1"/>
                       </a:pPr>
                       <a:r>
-                        <a:rPr sz="1100" b="1">
-                          <a:solidFill>
-                            <a:srgbClr val="FFFFFF"/>
-                          </a:solidFill>
-                          <a:latin typeface="Calibri"/>
-                        </a:rPr>
-                        <a:t>Key Finding</a:t>
+                        <a:t>Key Empirical Observation</a:t>
                       </a:r>
                     </a:p>
                   </a:txBody>
@@ -5451,20 +5205,9 @@
                     <a:lstStyle/>
                     <a:p>
                       <a:pPr>
-                        <a:spcBef>
-                          <a:spcPts val="100"/>
-                        </a:spcBef>
-                        <a:spcAft>
-                          <a:spcPts val="100"/>
-                        </a:spcAft>
+                        <a:defRPr sz="1000"/>
                       </a:pPr>
                       <a:r>
-                        <a:rPr sz="1050" b="0">
-                          <a:solidFill>
-                            <a:srgbClr val="1E293B"/>
-                          </a:solidFill>
-                          <a:latin typeface="Calibri"/>
-                        </a:rPr>
                         <a:t>Undefended Baseline</a:t>
                       </a:r>
                     </a:p>
@@ -5503,20 +5246,9 @@
                     <a:lstStyle/>
                     <a:p>
                       <a:pPr>
-                        <a:spcBef>
-                          <a:spcPts val="100"/>
-                        </a:spcBef>
-                        <a:spcAft>
-                          <a:spcPts val="100"/>
-                        </a:spcAft>
+                        <a:defRPr sz="1000"/>
                       </a:pPr>
                       <a:r>
-                        <a:rPr sz="1050" b="0">
-                          <a:solidFill>
-                            <a:srgbClr val="1E293B"/>
-                          </a:solidFill>
-                          <a:latin typeface="Calibri"/>
-                        </a:rPr>
                         <a:t>EN / BN / BN-EN</a:t>
                       </a:r>
                     </a:p>
@@ -5555,21 +5287,10 @@
                     <a:lstStyle/>
                     <a:p>
                       <a:pPr>
-                        <a:spcBef>
-                          <a:spcPts val="100"/>
-                        </a:spcBef>
-                        <a:spcAft>
-                          <a:spcPts val="100"/>
-                        </a:spcAft>
+                        <a:defRPr sz="1000"/>
                       </a:pPr>
                       <a:r>
-                        <a:rPr sz="1050" b="0">
-                          <a:solidFill>
-                            <a:srgbClr val="1E293B"/>
-                          </a:solidFill>
-                          <a:latin typeface="Calibri"/>
-                        </a:rPr>
-                        <a:t>100%</a:t>
+                        <a:t>100.0%</a:t>
                       </a:r>
                     </a:p>
                   </a:txBody>
@@ -5607,21 +5328,10 @@
                     <a:lstStyle/>
                     <a:p>
                       <a:pPr>
-                        <a:spcBef>
-                          <a:spcPts val="100"/>
-                        </a:spcBef>
-                        <a:spcAft>
-                          <a:spcPts val="100"/>
-                        </a:spcAft>
+                        <a:defRPr sz="1000"/>
                       </a:pPr>
                       <a:r>
-                        <a:rPr sz="1050" b="0">
-                          <a:solidFill>
-                            <a:srgbClr val="1E293B"/>
-                          </a:solidFill>
-                          <a:latin typeface="Calibri"/>
-                        </a:rPr>
-                        <a:t>100%</a:t>
+                        <a:t>100.0%</a:t>
                       </a:r>
                     </a:p>
                   </a:txBody>
@@ -5659,21 +5369,10 @@
                     <a:lstStyle/>
                     <a:p>
                       <a:pPr>
-                        <a:spcBef>
-                          <a:spcPts val="100"/>
-                        </a:spcBef>
-                        <a:spcAft>
-                          <a:spcPts val="100"/>
-                        </a:spcAft>
+                        <a:defRPr sz="1000"/>
                       </a:pPr>
                       <a:r>
-                        <a:rPr sz="1050" b="0">
-                          <a:solidFill>
-                            <a:srgbClr val="1E293B"/>
-                          </a:solidFill>
-                          <a:latin typeface="Calibri"/>
-                        </a:rPr>
-                        <a:t>100%</a:t>
+                        <a:t>100.0%</a:t>
                       </a:r>
                     </a:p>
                   </a:txBody>
@@ -5711,21 +5410,10 @@
                     <a:lstStyle/>
                     <a:p>
                       <a:pPr>
-                        <a:spcBef>
-                          <a:spcPts val="100"/>
-                        </a:spcBef>
-                        <a:spcAft>
-                          <a:spcPts val="100"/>
-                        </a:spcAft>
+                        <a:defRPr sz="1000"/>
                       </a:pPr>
                       <a:r>
-                        <a:rPr sz="1050" b="0">
-                          <a:solidFill>
-                            <a:srgbClr val="1E293B"/>
-                          </a:solidFill>
-                          <a:latin typeface="Calibri"/>
-                        </a:rPr>
-                        <a:t>Full exploitation across all registers</a:t>
+                        <a:t>Full exploitation across all registers; canary write executes with 100% ASR</a:t>
                       </a:r>
                     </a:p>
                   </a:txBody>
@@ -5765,21 +5453,10 @@
                     <a:lstStyle/>
                     <a:p>
                       <a:pPr>
-                        <a:spcBef>
-                          <a:spcPts val="100"/>
-                        </a:spcBef>
-                        <a:spcAft>
-                          <a:spcPts val="100"/>
-                        </a:spcAft>
+                        <a:defRPr sz="1000"/>
                       </a:pPr>
                       <a:r>
-                        <a:rPr sz="1050" b="0">
-                          <a:solidFill>
-                            <a:srgbClr val="1E293B"/>
-                          </a:solidFill>
-                          <a:latin typeface="Calibri"/>
-                        </a:rPr>
-                        <a:t>Static Keyword Scanner</a:t>
+                        <a:t>Static Scanner</a:t>
                       </a:r>
                     </a:p>
                   </a:txBody>
@@ -5817,40 +5494,15 @@
                     <a:lstStyle/>
                     <a:p>
                       <a:pPr>
-                        <a:spcBef>
-                          <a:spcPts val="100"/>
-                        </a:spcBef>
-                        <a:spcAft>
-                          <a:spcPts val="100"/>
-                        </a:spcAft>
+                        <a:defRPr sz="1000"/>
                       </a:pPr>
                       <a:r>
-                        <a:rPr sz="1050" b="0">
-                          <a:solidFill>
-                            <a:srgbClr val="1E293B"/>
-                          </a:solidFill>
-                          <a:latin typeface="Calibri"/>
-                        </a:rPr>
                         <a:t>English (en)</a:t>
                       </a:r>
                     </a:p>
                     <a:p>
-                      <a:pPr>
-                        <a:spcBef>
-                          <a:spcPts val="100"/>
-                        </a:spcBef>
-                        <a:spcAft>
-                          <a:spcPts val="100"/>
-                        </a:spcAft>
-                      </a:pPr>
                       <a:r>
-                        <a:rPr sz="1050" b="0">
-                          <a:solidFill>
-                            <a:srgbClr val="1E293B"/>
-                          </a:solidFill>
-                          <a:latin typeface="Calibri"/>
-                        </a:rPr>
-                        <a:t>Bangla (bn / bn-en)</a:t>
+                        <a:t>Bangla / Banglish</a:t>
                       </a:r>
                     </a:p>
                   </a:txBody>
@@ -5888,40 +5540,15 @@
                     <a:lstStyle/>
                     <a:p>
                       <a:pPr>
-                        <a:spcBef>
-                          <a:spcPts val="100"/>
-                        </a:spcBef>
-                        <a:spcAft>
-                          <a:spcPts val="100"/>
-                        </a:spcAft>
+                        <a:defRPr sz="1000"/>
                       </a:pPr>
                       <a:r>
-                        <a:rPr sz="1050" b="0">
-                          <a:solidFill>
-                            <a:srgbClr val="1E293B"/>
-                          </a:solidFill>
-                          <a:latin typeface="Calibri"/>
-                        </a:rPr>
-                        <a:t>0%</a:t>
+                        <a:t>76.9%</a:t>
                       </a:r>
                     </a:p>
                     <a:p>
-                      <a:pPr>
-                        <a:spcBef>
-                          <a:spcPts val="100"/>
-                        </a:spcBef>
-                        <a:spcAft>
-                          <a:spcPts val="100"/>
-                        </a:spcAft>
-                      </a:pPr>
                       <a:r>
-                        <a:rPr sz="1050" b="0">
-                          <a:solidFill>
-                            <a:srgbClr val="1E293B"/>
-                          </a:solidFill>
-                          <a:latin typeface="Calibri"/>
-                        </a:rPr>
-                        <a:t>100%</a:t>
+                        <a:t>100.0%</a:t>
                       </a:r>
                     </a:p>
                   </a:txBody>
@@ -5959,40 +5586,15 @@
                     <a:lstStyle/>
                     <a:p>
                       <a:pPr>
-                        <a:spcBef>
-                          <a:spcPts val="100"/>
-                        </a:spcBef>
-                        <a:spcAft>
-                          <a:spcPts val="100"/>
-                        </a:spcAft>
+                        <a:defRPr sz="1000"/>
                       </a:pPr>
                       <a:r>
-                        <a:rPr sz="1050" b="0">
-                          <a:solidFill>
-                            <a:srgbClr val="1E293B"/>
-                          </a:solidFill>
-                          <a:latin typeface="Calibri"/>
-                        </a:rPr>
-                        <a:t>0%</a:t>
+                        <a:t>76.9%</a:t>
                       </a:r>
                     </a:p>
                     <a:p>
-                      <a:pPr>
-                        <a:spcBef>
-                          <a:spcPts val="100"/>
-                        </a:spcBef>
-                        <a:spcAft>
-                          <a:spcPts val="100"/>
-                        </a:spcAft>
-                      </a:pPr>
                       <a:r>
-                        <a:rPr sz="1050" b="0">
-                          <a:solidFill>
-                            <a:srgbClr val="1E293B"/>
-                          </a:solidFill>
-                          <a:latin typeface="Calibri"/>
-                        </a:rPr>
-                        <a:t>100%</a:t>
+                        <a:t>100.0%</a:t>
                       </a:r>
                     </a:p>
                   </a:txBody>
@@ -6030,40 +5632,15 @@
                     <a:lstStyle/>
                     <a:p>
                       <a:pPr>
-                        <a:spcBef>
-                          <a:spcPts val="100"/>
-                        </a:spcBef>
-                        <a:spcAft>
-                          <a:spcPts val="100"/>
-                        </a:spcAft>
+                        <a:defRPr sz="1000"/>
                       </a:pPr>
                       <a:r>
-                        <a:rPr sz="1050" b="0">
-                          <a:solidFill>
-                            <a:srgbClr val="1E293B"/>
-                          </a:solidFill>
-                          <a:latin typeface="Calibri"/>
-                        </a:rPr>
-                        <a:t>0%</a:t>
+                        <a:t>76.9%</a:t>
                       </a:r>
                     </a:p>
                     <a:p>
-                      <a:pPr>
-                        <a:spcBef>
-                          <a:spcPts val="100"/>
-                        </a:spcBef>
-                        <a:spcAft>
-                          <a:spcPts val="100"/>
-                        </a:spcAft>
-                      </a:pPr>
                       <a:r>
-                        <a:rPr sz="1050" b="0">
-                          <a:solidFill>
-                            <a:srgbClr val="1E293B"/>
-                          </a:solidFill>
-                          <a:latin typeface="Calibri"/>
-                        </a:rPr>
-                        <a:t>100%</a:t>
+                        <a:t>100.0%</a:t>
                       </a:r>
                     </a:p>
                   </a:txBody>
@@ -6101,40 +5678,10 @@
                     <a:lstStyle/>
                     <a:p>
                       <a:pPr>
-                        <a:spcBef>
-                          <a:spcPts val="100"/>
-                        </a:spcBef>
-                        <a:spcAft>
-                          <a:spcPts val="100"/>
-                        </a:spcAft>
+                        <a:defRPr sz="1000"/>
                       </a:pPr>
                       <a:r>
-                        <a:rPr sz="1050" b="0">
-                          <a:solidFill>
-                            <a:srgbClr val="1E293B"/>
-                          </a:solidFill>
-                          <a:latin typeface="Calibri"/>
-                        </a:rPr>
-                        <a:t>Blocks English but kills utility (BUR=0%);</a:t>
-                      </a:r>
-                    </a:p>
-                    <a:p>
-                      <a:pPr>
-                        <a:spcBef>
-                          <a:spcPts val="100"/>
-                        </a:spcBef>
-                        <a:spcAft>
-                          <a:spcPts val="100"/>
-                        </a:spcAft>
-                      </a:pPr>
-                      <a:r>
-                        <a:rPr sz="1050" b="0">
-                          <a:solidFill>
-                            <a:srgbClr val="1E293B"/>
-                          </a:solidFill>
-                          <a:latin typeface="Calibri"/>
-                        </a:rPr>
-                        <a:t>Total bypass on Bangla/Banglish (ASR=100%)</a:t>
+                        <a:t>23.1% False Denial Rate on English; 100% total bypass on BN and BN-EN</a:t>
                       </a:r>
                     </a:p>
                   </a:txBody>
@@ -6174,21 +5721,10 @@
                     <a:lstStyle/>
                     <a:p>
                       <a:pPr>
-                        <a:spcBef>
-                          <a:spcPts val="100"/>
-                        </a:spcBef>
-                        <a:spcAft>
-                          <a:spcPts val="100"/>
-                        </a:spcAft>
+                        <a:defRPr sz="1000"/>
                       </a:pPr>
                       <a:r>
-                        <a:rPr sz="1050" b="0">
-                          <a:solidFill>
-                            <a:srgbClr val="1E293B"/>
-                          </a:solidFill>
-                          <a:latin typeface="Calibri"/>
-                        </a:rPr>
-                        <a:t>Prompt-Level Isolation</a:t>
+                        <a:t>Prompt Isolation</a:t>
                       </a:r>
                     </a:p>
                   </a:txBody>
@@ -6226,40 +5762,20 @@
                     <a:lstStyle/>
                     <a:p>
                       <a:pPr>
-                        <a:spcBef>
-                          <a:spcPts val="100"/>
-                        </a:spcBef>
-                        <a:spcAft>
-                          <a:spcPts val="100"/>
-                        </a:spcAft>
+                        <a:defRPr sz="1000"/>
                       </a:pPr>
                       <a:r>
-                        <a:rPr sz="1050" b="0">
-                          <a:solidFill>
-                            <a:srgbClr val="1E293B"/>
-                          </a:solidFill>
-                          <a:latin typeface="Calibri"/>
-                        </a:rPr>
                         <a:t>English (en)</a:t>
                       </a:r>
                     </a:p>
                     <a:p>
-                      <a:pPr>
-                        <a:spcBef>
-                          <a:spcPts val="100"/>
-                        </a:spcBef>
-                        <a:spcAft>
-                          <a:spcPts val="100"/>
-                        </a:spcAft>
-                      </a:pPr>
                       <a:r>
-                        <a:rPr sz="1050" b="0">
-                          <a:solidFill>
-                            <a:srgbClr val="1E293B"/>
-                          </a:solidFill>
-                          <a:latin typeface="Calibri"/>
-                        </a:rPr>
-                        <a:t>Bangla (bn / bn-en)</a:t>
+                        <a:t>Bangla (bn)</a:t>
+                      </a:r>
+                    </a:p>
+                    <a:p>
+                      <a:r>
+                        <a:t>Banglish (bn-en)</a:t>
                       </a:r>
                     </a:p>
                   </a:txBody>
@@ -6297,40 +5813,20 @@
                     <a:lstStyle/>
                     <a:p>
                       <a:pPr>
-                        <a:spcBef>
-                          <a:spcPts val="100"/>
-                        </a:spcBef>
-                        <a:spcAft>
-                          <a:spcPts val="100"/>
-                        </a:spcAft>
+                        <a:defRPr sz="1000"/>
                       </a:pPr>
                       <a:r>
-                        <a:rPr sz="1050" b="0">
-                          <a:solidFill>
-                            <a:srgbClr val="1E293B"/>
-                          </a:solidFill>
-                          <a:latin typeface="Calibri"/>
-                        </a:rPr>
-                        <a:t>100%</a:t>
+                        <a:t>7.7%</a:t>
                       </a:r>
                     </a:p>
                     <a:p>
-                      <a:pPr>
-                        <a:spcBef>
-                          <a:spcPts val="100"/>
-                        </a:spcBef>
-                        <a:spcAft>
-                          <a:spcPts val="100"/>
-                        </a:spcAft>
-                      </a:pPr>
                       <a:r>
-                        <a:rPr sz="1050" b="0">
-                          <a:solidFill>
-                            <a:srgbClr val="1E293B"/>
-                          </a:solidFill>
-                          <a:latin typeface="Calibri"/>
-                        </a:rPr>
-                        <a:t>100%</a:t>
+                        <a:t>3.8%</a:t>
+                      </a:r>
+                    </a:p>
+                    <a:p>
+                      <a:r>
+                        <a:t>0.0%</a:t>
                       </a:r>
                     </a:p>
                   </a:txBody>
@@ -6368,40 +5864,20 @@
                     <a:lstStyle/>
                     <a:p>
                       <a:pPr>
-                        <a:spcBef>
-                          <a:spcPts val="100"/>
-                        </a:spcBef>
-                        <a:spcAft>
-                          <a:spcPts val="100"/>
-                        </a:spcAft>
+                        <a:defRPr sz="1000"/>
                       </a:pPr>
                       <a:r>
-                        <a:rPr sz="1050" b="0">
-                          <a:solidFill>
-                            <a:srgbClr val="1E293B"/>
-                          </a:solidFill>
-                          <a:latin typeface="Calibri"/>
-                        </a:rPr>
-                        <a:t>0%</a:t>
+                        <a:t>7.7%</a:t>
                       </a:r>
                     </a:p>
                     <a:p>
-                      <a:pPr>
-                        <a:spcBef>
-                          <a:spcPts val="100"/>
-                        </a:spcBef>
-                        <a:spcAft>
-                          <a:spcPts val="100"/>
-                        </a:spcAft>
-                      </a:pPr>
                       <a:r>
-                        <a:rPr sz="1050" b="0">
-                          <a:solidFill>
-                            <a:srgbClr val="1E293B"/>
-                          </a:solidFill>
-                          <a:latin typeface="Calibri"/>
-                        </a:rPr>
-                        <a:t>100%</a:t>
+                        <a:t>3.8%</a:t>
+                      </a:r>
+                    </a:p>
+                    <a:p>
+                      <a:r>
+                        <a:t>0.0%</a:t>
                       </a:r>
                     </a:p>
                   </a:txBody>
@@ -6439,40 +5915,20 @@
                     <a:lstStyle/>
                     <a:p>
                       <a:pPr>
-                        <a:spcBef>
-                          <a:spcPts val="100"/>
-                        </a:spcBef>
-                        <a:spcAft>
-                          <a:spcPts val="100"/>
-                        </a:spcAft>
+                        <a:defRPr sz="1000"/>
                       </a:pPr>
                       <a:r>
-                        <a:rPr sz="1050" b="0">
-                          <a:solidFill>
-                            <a:srgbClr val="1E293B"/>
-                          </a:solidFill>
-                          <a:latin typeface="Calibri"/>
-                        </a:rPr>
-                        <a:t>100%</a:t>
+                        <a:t>76.9%</a:t>
                       </a:r>
                     </a:p>
                     <a:p>
-                      <a:pPr>
-                        <a:spcBef>
-                          <a:spcPts val="100"/>
-                        </a:spcBef>
-                        <a:spcAft>
-                          <a:spcPts val="100"/>
-                        </a:spcAft>
-                      </a:pPr>
                       <a:r>
-                        <a:rPr sz="1050" b="0">
-                          <a:solidFill>
-                            <a:srgbClr val="1E293B"/>
-                          </a:solidFill>
-                          <a:latin typeface="Calibri"/>
-                        </a:rPr>
-                        <a:t>100%</a:t>
+                        <a:t>84.6%</a:t>
+                      </a:r>
+                    </a:p>
+                    <a:p>
+                      <a:r>
+                        <a:t>84.6%</a:t>
                       </a:r>
                     </a:p>
                   </a:txBody>
@@ -6510,40 +5966,10 @@
                     <a:lstStyle/>
                     <a:p>
                       <a:pPr>
-                        <a:spcBef>
-                          <a:spcPts val="100"/>
-                        </a:spcBef>
-                        <a:spcAft>
-                          <a:spcPts val="100"/>
-                        </a:spcAft>
+                        <a:defRPr sz="1000"/>
                       </a:pPr>
                       <a:r>
-                        <a:rPr sz="1050" b="0">
-                          <a:solidFill>
-                            <a:srgbClr val="1E293B"/>
-                          </a:solidFill>
-                          <a:latin typeface="Calibri"/>
-                        </a:rPr>
-                        <a:t>Mitigates English prompts effectively;</a:t>
-                      </a:r>
-                    </a:p>
-                    <a:p>
-                      <a:pPr>
-                        <a:spcBef>
-                          <a:spcPts val="100"/>
-                        </a:spcBef>
-                        <a:spcAft>
-                          <a:spcPts val="100"/>
-                        </a:spcAft>
-                      </a:pPr>
-                      <a:r>
-                        <a:rPr sz="1050" b="0">
-                          <a:solidFill>
-                            <a:srgbClr val="1E293B"/>
-                          </a:solidFill>
-                          <a:latin typeface="Calibri"/>
-                        </a:rPr>
-                        <a:t>Fails cross-lingually (ASR=100%)</a:t>
+                        <a:t>Suppresses raw injection but induces utility collapse (TSR falls to 76.9%)</a:t>
                       </a:r>
                     </a:p>
                   </a:txBody>
@@ -6583,20 +6009,9 @@
                     <a:lstStyle/>
                     <a:p>
                       <a:pPr>
-                        <a:spcBef>
-                          <a:spcPts val="100"/>
-                        </a:spcBef>
-                        <a:spcAft>
-                          <a:spcPts val="100"/>
-                        </a:spcAft>
+                        <a:defRPr sz="1000"/>
                       </a:pPr>
                       <a:r>
-                        <a:rPr sz="1050" b="0">
-                          <a:solidFill>
-                            <a:srgbClr val="1E293B"/>
-                          </a:solidFill>
-                          <a:latin typeface="Calibri"/>
-                        </a:rPr>
                         <a:t>Policy Module (ADR-0002)</a:t>
                       </a:r>
                     </a:p>
@@ -6635,20 +6050,9 @@
                     <a:lstStyle/>
                     <a:p>
                       <a:pPr>
-                        <a:spcBef>
-                          <a:spcPts val="100"/>
-                        </a:spcBef>
-                        <a:spcAft>
-                          <a:spcPts val="100"/>
-                        </a:spcAft>
+                        <a:defRPr sz="1000"/>
                       </a:pPr>
                       <a:r>
-                        <a:rPr sz="1050" b="0">
-                          <a:solidFill>
-                            <a:srgbClr val="1E293B"/>
-                          </a:solidFill>
-                          <a:latin typeface="Calibri"/>
-                        </a:rPr>
                         <a:t>EN / BN / BN-EN</a:t>
                       </a:r>
                     </a:p>
@@ -6687,21 +6091,10 @@
                     <a:lstStyle/>
                     <a:p>
                       <a:pPr>
-                        <a:spcBef>
-                          <a:spcPts val="100"/>
-                        </a:spcBef>
-                        <a:spcAft>
-                          <a:spcPts val="100"/>
-                        </a:spcAft>
+                        <a:defRPr sz="1000"/>
                       </a:pPr>
                       <a:r>
-                        <a:rPr sz="1050" b="0">
-                          <a:solidFill>
-                            <a:srgbClr val="1E293B"/>
-                          </a:solidFill>
-                          <a:latin typeface="Calibri"/>
-                        </a:rPr>
-                        <a:t>100%</a:t>
+                        <a:t>0.0%</a:t>
                       </a:r>
                     </a:p>
                   </a:txBody>
@@ -6739,21 +6132,10 @@
                     <a:lstStyle/>
                     <a:p>
                       <a:pPr>
-                        <a:spcBef>
-                          <a:spcPts val="100"/>
-                        </a:spcBef>
-                        <a:spcAft>
-                          <a:spcPts val="100"/>
-                        </a:spcAft>
+                        <a:defRPr sz="1000"/>
                       </a:pPr>
                       <a:r>
-                        <a:rPr sz="1050" b="0">
-                          <a:solidFill>
-                            <a:srgbClr val="1E293B"/>
-                          </a:solidFill>
-                          <a:latin typeface="Calibri"/>
-                        </a:rPr>
-                        <a:t>0%</a:t>
+                        <a:t>0.0%</a:t>
                       </a:r>
                     </a:p>
                   </a:txBody>
@@ -6791,21 +6173,10 @@
                     <a:lstStyle/>
                     <a:p>
                       <a:pPr>
-                        <a:spcBef>
-                          <a:spcPts val="100"/>
-                        </a:spcBef>
-                        <a:spcAft>
-                          <a:spcPts val="100"/>
-                        </a:spcAft>
+                        <a:defRPr sz="1000"/>
                       </a:pPr>
                       <a:r>
-                        <a:rPr sz="1050" b="0">
-                          <a:solidFill>
-                            <a:srgbClr val="1E293B"/>
-                          </a:solidFill>
-                          <a:latin typeface="Calibri"/>
-                        </a:rPr>
-                        <a:t>100%</a:t>
+                        <a:t>100.0%</a:t>
                       </a:r>
                     </a:p>
                   </a:txBody>
@@ -6843,21 +6214,10 @@
                     <a:lstStyle/>
                     <a:p>
                       <a:pPr>
-                        <a:spcBef>
-                          <a:spcPts val="100"/>
-                        </a:spcBef>
-                        <a:spcAft>
-                          <a:spcPts val="100"/>
-                        </a:spcAft>
+                        <a:defRPr sz="1000"/>
                       </a:pPr>
                       <a:r>
-                        <a:rPr sz="1050" b="0">
-                          <a:solidFill>
-                            <a:srgbClr val="1E293B"/>
-                          </a:solidFill>
-                          <a:latin typeface="Calibri"/>
-                        </a:rPr>
-                        <a:t>Language-invariant zero ASR with 100% BUR</a:t>
+                        <a:t>Language-invariant 0% ASR, 100% TSR, 0% FDR with 0.038ms latency overhead</a:t>
                       </a:r>
                     </a:p>
                   </a:txBody>
@@ -7017,150 +6377,34 @@
           <a:lstStyle/>
           <a:p>
             <a:pPr>
-              <a:spcBef>
-                <a:spcPts val="200"/>
-              </a:spcBef>
-              <a:spcAft>
-                <a:spcPts val="600"/>
-              </a:spcAft>
+              <a:defRPr sz="1050"/>
             </a:pPr>
             <a:r>
-              <a:rPr sz="1300" b="1" i="0">
-                <a:solidFill>
-                  <a:srgbClr val="1C4587"/>
-                </a:solidFill>
-                <a:latin typeface="Calibri"/>
-              </a:rPr>
-              <a:t>•  </a:t>
-            </a:r>
-            <a:r>
-              <a:rPr sz="1300" b="1" i="0">
-                <a:solidFill>
-                  <a:srgbClr val="1C4587"/>
-                </a:solidFill>
-                <a:latin typeface="Calibri"/>
-              </a:rPr>
-              <a:t>Vulnerability Extends to Tool Loops: </a:t>
-            </a:r>
-            <a:r>
-              <a:rPr sz="1300" b="0" i="0">
-                <a:solidFill>
-                  <a:srgbClr val="1E293B"/>
-                </a:solidFill>
-                <a:latin typeface="Calibri"/>
-              </a:rPr>
-              <a:t>Models comprehended malicious instructions across Bangla and code-mixed Banglish with 100% fidelity, disproving the assumption that low-resource phrasing disrupts execution.</a:t>
+              <a:t>•  Cross-Lingual Evasion: 100% of malicious skills in Bangla (bn) and Banglish (bn-en) bypassed install-time regex scanners due to the English calibration gap.</a:t>
             </a:r>
           </a:p>
           <a:p>
             <a:pPr>
-              <a:spcBef>
-                <a:spcPts val="200"/>
-              </a:spcBef>
-              <a:spcAft>
-                <a:spcPts val="600"/>
-              </a:spcAft>
+              <a:defRPr sz="1050"/>
             </a:pPr>
             <a:r>
-              <a:rPr sz="1300" b="1" i="0">
-                <a:solidFill>
-                  <a:srgbClr val="1C4587"/>
-                </a:solidFill>
-                <a:latin typeface="Calibri"/>
-              </a:rPr>
-              <a:t>•  </a:t>
-            </a:r>
-            <a:r>
-              <a:rPr sz="1300" b="1" i="0">
-                <a:solidFill>
-                  <a:srgbClr val="1C4587"/>
-                </a:solidFill>
-                <a:latin typeface="Calibri"/>
-              </a:rPr>
-              <a:t>Total Scanner Evasion: </a:t>
-            </a:r>
-            <a:r>
-              <a:rPr sz="1300" b="0" i="0">
-                <a:solidFill>
-                  <a:srgbClr val="1E293B"/>
-                </a:solidFill>
-                <a:latin typeface="Calibri"/>
-              </a:rPr>
-              <a:t>Static keyword screening exhibited zero detection on Bangla and Banglish manifests, allowing 100% of non-English attacks to slip through install-time vetting completely unnoticed.</a:t>
+              <a:t>•  High Scanner False Denials: Keyword matching blocked 23.1% of benign English skills, severely penalizing legitimate developers and users.</a:t>
             </a:r>
           </a:p>
           <a:p>
             <a:pPr>
-              <a:spcBef>
-                <a:spcPts val="200"/>
-              </a:spcBef>
-              <a:spcAft>
-                <a:spcPts val="600"/>
-              </a:spcAft>
+              <a:defRPr sz="1050"/>
             </a:pPr>
             <a:r>
-              <a:rPr sz="1300" b="1" i="0">
-                <a:solidFill>
-                  <a:srgbClr val="1C4587"/>
-                </a:solidFill>
-                <a:latin typeface="Calibri"/>
-              </a:rPr>
-              <a:t>•  </a:t>
-            </a:r>
-            <a:r>
-              <a:rPr sz="1300" b="1" i="0">
-                <a:solidFill>
-                  <a:srgbClr val="1C4587"/>
-                </a:solidFill>
-                <a:latin typeface="Calibri"/>
-              </a:rPr>
-              <a:t>Prompt Guardrail Degradation: </a:t>
-            </a:r>
-            <a:r>
-              <a:rPr sz="1300" b="0" i="0">
-                <a:solidFill>
-                  <a:srgbClr val="1E293B"/>
-                </a:solidFill>
-                <a:latin typeface="Calibri"/>
-              </a:rPr>
-              <a:t>While prompt-level security warnings dropped English ASR to 0%, they proved entirely ineffective against Bangla and Banglish, yielding 100% ASR due to safety calibration disparities.</a:t>
+              <a:t>•  Prompt Isolation Utility Loss: Soft system prompt instructions confused the LLM planner, reducing legitimate Task Success Rate (TSR) by up to 23.1%.</a:t>
             </a:r>
           </a:p>
           <a:p>
             <a:pPr>
-              <a:spcBef>
-                <a:spcPts val="200"/>
-              </a:spcBef>
-              <a:spcAft>
-                <a:spcPts val="600"/>
-              </a:spcAft>
+              <a:defRPr sz="1050"/>
             </a:pPr>
             <a:r>
-              <a:rPr sz="1300" b="1" i="0">
-                <a:solidFill>
-                  <a:srgbClr val="1C4587"/>
-                </a:solidFill>
-                <a:latin typeface="Calibri"/>
-              </a:rPr>
-              <a:t>•  </a:t>
-            </a:r>
-            <a:r>
-              <a:rPr sz="1300" b="1" i="0">
-                <a:solidFill>
-                  <a:srgbClr val="1C4587"/>
-                </a:solidFill>
-                <a:latin typeface="Calibri"/>
-              </a:rPr>
-              <a:t>Deterministic Language Invariance: </a:t>
-            </a:r>
-            <a:r>
-              <a:rPr sz="1300" b="0" i="0">
-                <a:solidFill>
-                  <a:srgbClr val="1E293B"/>
-                </a:solidFill>
-                <a:latin typeface="Calibri"/>
-              </a:rPr>
-              <a:t>The ADR-0002 Policy Enforcement Module achieved 0% ASR and 100% BUR across all 120 trials, demonstrating that physical dispatch-seam validation eliminates linguistic dependencies entirely.</a:t>
+              <a:t>•  Deterministic Protection: ADR-0002 policy enforcement achieved 0% ASR, 100% TSR, and 0% FDR across all 312 trials with only 0.038ms overhead.</a:t>
             </a:r>
           </a:p>
         </p:txBody>
@@ -7289,114 +6533,34 @@
           <a:lstStyle/>
           <a:p>
             <a:pPr>
-              <a:spcBef>
-                <a:spcPts val="200"/>
-              </a:spcBef>
-              <a:spcAft>
-                <a:spcPts val="600"/>
-              </a:spcAft>
+              <a:defRPr sz="1050"/>
             </a:pPr>
             <a:r>
-              <a:rPr sz="1300" b="1" i="0">
-                <a:solidFill>
-                  <a:srgbClr val="1C4587"/>
-                </a:solidFill>
-                <a:latin typeface="Calibri"/>
-              </a:rPr>
-              <a:t>1.  First Runtime Cross-Lingual Evaluation: </a:t>
-            </a:r>
-            <a:r>
-              <a:rPr sz="1300" b="0" i="0">
-                <a:solidFill>
-                  <a:srgbClr val="1E293B"/>
-                </a:solidFill>
-                <a:latin typeface="Calibri"/>
-              </a:rPr>
-              <a:t>Established the first benchmark measuring live execution outcomes of multilingual agent skill poisoning.</a:t>
+              <a:t>1.  First 26-Domain Cross-Lingual Benchmark: Evaluated 312 live runtime trials across English, Bangla, and Banglish against frontier LLMs.</a:t>
             </a:r>
           </a:p>
           <a:p>
             <a:pPr>
-              <a:spcBef>
-                <a:spcPts val="200"/>
-              </a:spcBef>
-              <a:spcAft>
-                <a:spcPts val="600"/>
-              </a:spcAft>
+              <a:defRPr sz="1050"/>
             </a:pPr>
             <a:r>
-              <a:rPr sz="1300" b="1" i="0">
-                <a:solidFill>
-                  <a:srgbClr val="1C4587"/>
-                </a:solidFill>
-                <a:latin typeface="Calibri"/>
-              </a:rPr>
-              <a:t>2.  Empirical Validation of Scanner Bias: </a:t>
-            </a:r>
-            <a:r>
-              <a:rPr sz="1300" b="0" i="0">
-                <a:solidFill>
-                  <a:srgbClr val="1E293B"/>
-                </a:solidFill>
-                <a:latin typeface="Calibri"/>
-              </a:rPr>
-              <a:t>Quantified the real-world operational security failure of English-calibrated marketplace vetting tools.</a:t>
+              <a:t>2.  Rug-Pull Attack Formalization: Identified Stage 4 local file mutation vectors where dynamic updates bypass install-time authorization.</a:t>
             </a:r>
           </a:p>
           <a:p>
             <a:pPr>
-              <a:spcBef>
-                <a:spcPts val="200"/>
-              </a:spcBef>
-              <a:spcAft>
-                <a:spcPts val="600"/>
-              </a:spcAft>
+              <a:defRPr sz="1050"/>
             </a:pPr>
             <a:r>
-              <a:rPr sz="1300" b="1" i="0">
-                <a:solidFill>
-                  <a:srgbClr val="1C4587"/>
-                </a:solidFill>
-                <a:latin typeface="Calibri"/>
-              </a:rPr>
-              <a:t>3.  Language-Invariant Defense Architecture: </a:t>
-            </a:r>
-            <a:r>
-              <a:rPr sz="1300" b="0" i="0">
-                <a:solidFill>
-                  <a:srgbClr val="1E293B"/>
-                </a:solidFill>
-                <a:latin typeface="Calibri"/>
-              </a:rPr>
-              <a:t>Validated an in-process deterministic policy enforcement pattern (ADR-0002) that guarantees zero execution hijack regardless of prompt language.</a:t>
+              <a:t>3.  Deterministic Runtime Seam: Validated that programmatic path invariants at dispatch(request, context) provide language-invariant safety.</a:t>
             </a:r>
           </a:p>
           <a:p>
             <a:pPr>
-              <a:spcBef>
-                <a:spcPts val="200"/>
-              </a:spcBef>
-              <a:spcAft>
-                <a:spcPts val="600"/>
-              </a:spcAft>
+              <a:defRPr sz="1050"/>
             </a:pPr>
             <a:r>
-              <a:rPr sz="1300" b="1" i="0">
-                <a:solidFill>
-                  <a:srgbClr val="1C4587"/>
-                </a:solidFill>
-                <a:latin typeface="Calibri"/>
-              </a:rPr>
-              <a:t>4.  Reproducible Open-Source Artifacts: </a:t>
-            </a:r>
-            <a:r>
-              <a:rPr sz="1300" b="0" i="0">
-                <a:solidFill>
-                  <a:srgbClr val="1E293B"/>
-                </a:solidFill>
-                <a:latin typeface="Calibri"/>
-              </a:rPr>
-              <a:t>Released complete task specifications, bilingual prompts, and 120 JSONL execution traces.</a:t>
+              <a:t>4.  Current Progress &amp; Roadmap: Scaling to 50 enterprise domains, evaluating multi-agent cascades, and preparing top-tier conference paper submission.</a:t>
             </a:r>
           </a:p>
         </p:txBody>

</xml_diff>